<commit_message>
docs: atualizar documentação completa para tag v2
- PPTX/DOCX regenerados com: ES 7.17.24, Langfuse 2.x, ProxyLLM, 6 e2e
- Slide 1: versão 2; slide 15: título inclui 6 E2E; slide 17: KPI "6 testes e2e"
- DOCX: tabela de serviços com ProxyLLM + notas de compatibilidade ES/Langfuse
- DOCX: métricas com 6 e2e validados; Makefile com make test-e2e e make proxy
- CLAUDE.md e README-bootstrap.md já atualizados na sessão anterior
</commit_message>
<xml_diff>
--- a/docs/fhir-forge-arquitetura.pptx
+++ b/docs/fhir-forge-arquitetura.pptx
@@ -3296,7 +3296,7 @@
                   <a:srgbClr val="FFFFFF"/>
                 </a:solidFill>
               </a:rPr>
-              <a:t>Versão 0.1.0  |  Abril 2026  |  Apache-2.0  |  Cassiano Moralles</a:t>
+              <a:t>Versão 2  |  Abril 2026  |  Apache-2.0  |  Cassiano Moralles</a:t>
             </a:r>
           </a:p>
         </p:txBody>
@@ -4043,7 +4043,7 @@
                   <a:srgbClr val="6B7280"/>
                 </a:solidFill>
               </a:rPr>
-              <a:t>FHIR-Forge v0.1.0  |  Abril 2026  |  Apache-2.0  |  Cassiano Moralles</a:t>
+              <a:t>FHIR-Forge v2  |  Abril 2026  |  Apache-2.0  |  Cassiano Moralles</a:t>
             </a:r>
           </a:p>
         </p:txBody>
@@ -4999,7 +4999,7 @@
                   <a:srgbClr val="6B7280"/>
                 </a:solidFill>
               </a:rPr>
-              <a:t>FHIR-Forge v0.1.0  |  Abril 2026  |  Apache-2.0  |  Cassiano Moralles</a:t>
+              <a:t>FHIR-Forge v2  |  Abril 2026  |  Apache-2.0  |  Cassiano Moralles</a:t>
             </a:r>
           </a:p>
         </p:txBody>
@@ -6178,7 +6178,7 @@
                   <a:srgbClr val="6B7280"/>
                 </a:solidFill>
               </a:rPr>
-              <a:t>FHIR-Forge v0.1.0  |  Abril 2026  |  Apache-2.0  |  Cassiano Moralles</a:t>
+              <a:t>FHIR-Forge v2  |  Abril 2026  |  Apache-2.0  |  Cassiano Moralles</a:t>
             </a:r>
           </a:p>
         </p:txBody>
@@ -7684,7 +7684,7 @@
                   <a:srgbClr val="6B7280"/>
                 </a:solidFill>
               </a:rPr>
-              <a:t>FHIR-Forge v0.1.0  |  Abril 2026  |  Apache-2.0  |  Cassiano Moralles</a:t>
+              <a:t>FHIR-Forge v2  |  Abril 2026  |  Apache-2.0  |  Cassiano Moralles</a:t>
             </a:r>
           </a:p>
         </p:txBody>
@@ -8493,7 +8493,7 @@
                   <a:srgbClr val="6B7280"/>
                 </a:solidFill>
               </a:rPr>
-              <a:t>FHIR-Forge v0.1.0  |  Abril 2026  |  Apache-2.0  |  Cassiano Moralles</a:t>
+              <a:t>FHIR-Forge v2  |  Abril 2026  |  Apache-2.0  |  Cassiano Moralles</a:t>
             </a:r>
           </a:p>
         </p:txBody>
@@ -8570,7 +8570,7 @@
                   <a:srgbClr val="FFFFFF"/>
                 </a:solidFill>
               </a:rPr>
-              <a:t>  Estratégia de Testes: 252 Testes, 91% de Cobertura</a:t>
+              <a:t>  Estratégia de Testes: 252 Unit + 6 E2E, 91% de Cobertura</a:t>
             </a:r>
           </a:p>
         </p:txBody>
@@ -10257,7 +10257,7 @@
                   <a:srgbClr val="1A1A2E"/>
                 </a:solidFill>
               </a:rPr>
-              <a:t>Docker stack completa</a:t>
+              <a:t>Anthropic API real + HAPI real</a:t>
             </a:r>
           </a:p>
         </p:txBody>
@@ -10336,7 +10336,7 @@
                   <a:srgbClr val="1A1A2E"/>
                 </a:solidFill>
               </a:rPr>
-              <a:t>Saga OpenAPI → Bundle</a:t>
+              <a:t>OpenAPI → LangGraph → Bundle (6 testes)</a:t>
             </a:r>
           </a:p>
         </p:txBody>
@@ -11296,7 +11296,7 @@
                   <a:srgbClr val="6B7280"/>
                 </a:solidFill>
               </a:rPr>
-              <a:t>FHIR-Forge v0.1.0  |  Abril 2026  |  Apache-2.0  |  Cassiano Moralles</a:t>
+              <a:t>FHIR-Forge v2  |  Abril 2026  |  Apache-2.0  |  Cassiano Moralles</a:t>
             </a:r>
           </a:p>
         </p:txBody>
@@ -12347,7 +12347,7 @@
                   <a:srgbClr val="6B7280"/>
                 </a:solidFill>
               </a:rPr>
-              <a:t>FHIR-Forge v0.1.0  |  Abril 2026  |  Apache-2.0  |  Cassiano Moralles</a:t>
+              <a:t>FHIR-Forge v2  |  Abril 2026  |  Apache-2.0  |  Cassiano Moralles</a:t>
             </a:r>
           </a:p>
         </p:txBody>
@@ -12616,7 +12616,7 @@
                   <a:srgbClr val="FFFFFF"/>
                 </a:solidFill>
               </a:rPr>
-              <a:t>91%</a:t>
+              <a:t>6</a:t>
             </a:r>
           </a:p>
         </p:txBody>
@@ -12650,7 +12650,7 @@
                   <a:srgbClr val="FFFFFF"/>
                 </a:solidFill>
               </a:rPr>
-              <a:t>cobertura de código</a:t>
+              <a:t>testes e2e validados</a:t>
             </a:r>
           </a:p>
         </p:txBody>
@@ -12729,7 +12729,7 @@
                   <a:srgbClr val="FFFFFF"/>
                 </a:solidFill>
               </a:rPr>
-              <a:t>9/9</a:t>
+              <a:t>91%</a:t>
             </a:r>
           </a:p>
         </p:txBody>
@@ -12763,7 +12763,7 @@
                   <a:srgbClr val="FFFFFF"/>
                 </a:solidFill>
               </a:rPr>
-              <a:t>fases completas</a:t>
+              <a:t>cobertura de código</a:t>
             </a:r>
           </a:p>
         </p:txBody>
@@ -12910,7 +12910,7 @@
                   <a:srgbClr val="0D2137"/>
                 </a:solidFill>
               </a:rPr>
-              <a:t>Próximos Passos:</a:t>
+              <a:t>Próximos Passos (v3):</a:t>
             </a:r>
           </a:p>
         </p:txBody>
@@ -13377,7 +13377,7 @@
                   <a:srgbClr val="6B7280"/>
                 </a:solidFill>
               </a:rPr>
-              <a:t>FHIR-Forge v0.1.0  |  Abril 2026  |  Apache-2.0  |  Cassiano Moralles</a:t>
+              <a:t>FHIR-Forge v2  |  Abril 2026  |  Apache-2.0  |  Cassiano Moralles</a:t>
             </a:r>
           </a:p>
         </p:txBody>
@@ -14166,7 +14166,7 @@
                   <a:srgbClr val="6B7280"/>
                 </a:solidFill>
               </a:rPr>
-              <a:t>FHIR-Forge v0.1.0  |  Abril 2026  |  Apache-2.0  |  Cassiano Moralles</a:t>
+              <a:t>FHIR-Forge v2  |  Abril 2026  |  Apache-2.0  |  Cassiano Moralles</a:t>
             </a:r>
           </a:p>
         </p:txBody>
@@ -14787,7 +14787,7 @@
                   <a:srgbClr val="6B7280"/>
                 </a:solidFill>
               </a:rPr>
-              <a:t>FHIR-Forge v0.1.0  |  Abril 2026  |  Apache-2.0  |  Cassiano Moralles</a:t>
+              <a:t>FHIR-Forge v2  |  Abril 2026  |  Apache-2.0  |  Cassiano Moralles</a:t>
             </a:r>
           </a:p>
         </p:txBody>
@@ -15516,7 +15516,7 @@
                   <a:srgbClr val="6B7280"/>
                 </a:solidFill>
               </a:rPr>
-              <a:t>FHIR-Forge v0.1.0  |  Abril 2026  |  Apache-2.0  |  Cassiano Moralles</a:t>
+              <a:t>FHIR-Forge v2  |  Abril 2026  |  Apache-2.0  |  Cassiano Moralles</a:t>
             </a:r>
           </a:p>
         </p:txBody>
@@ -16328,7 +16328,7 @@
                   <a:srgbClr val="6B7280"/>
                 </a:solidFill>
               </a:rPr>
-              <a:t>FHIR-Forge v0.1.0  |  Abril 2026  |  Apache-2.0  |  Cassiano Moralles</a:t>
+              <a:t>FHIR-Forge v2  |  Abril 2026  |  Apache-2.0  |  Cassiano Moralles</a:t>
             </a:r>
           </a:p>
         </p:txBody>
@@ -17148,7 +17148,7 @@
                   <a:srgbClr val="6B7280"/>
                 </a:solidFill>
               </a:rPr>
-              <a:t>FHIR-Forge v0.1.0  |  Abril 2026  |  Apache-2.0  |  Cassiano Moralles</a:t>
+              <a:t>FHIR-Forge v2  |  Abril 2026  |  Apache-2.0  |  Cassiano Moralles</a:t>
             </a:r>
           </a:p>
         </p:txBody>
@@ -17800,7 +17800,7 @@
                   <a:srgbClr val="6B7280"/>
                 </a:solidFill>
               </a:rPr>
-              <a:t>FHIR-Forge v0.1.0  |  Abril 2026  |  Apache-2.0  |  Cassiano Moralles</a:t>
+              <a:t>FHIR-Forge v2  |  Abril 2026  |  Apache-2.0  |  Cassiano Moralles</a:t>
             </a:r>
           </a:p>
         </p:txBody>
@@ -18250,7 +18250,7 @@
                   <a:srgbClr val="FFFFFF"/>
                 </a:solidFill>
               </a:rPr>
-              <a:t>Elasticsearch 8.11.1</a:t>
+              <a:t>Elasticsearch 7.17.24</a:t>
             </a:r>
           </a:p>
         </p:txBody>
@@ -18838,7 +18838,7 @@
                   <a:srgbClr val="FFFFFF"/>
                 </a:solidFill>
               </a:rPr>
-              <a:t>Langfuse 3.x</a:t>
+              <a:t>Langfuse 2.x</a:t>
             </a:r>
           </a:p>
         </p:txBody>
@@ -18985,7 +18985,7 @@
                   <a:srgbClr val="FFFFFF"/>
                 </a:solidFill>
               </a:rPr>
-              <a:t>FastAPI App</a:t>
+              <a:t>ProxyLLM</a:t>
             </a:r>
           </a:p>
         </p:txBody>
@@ -19019,7 +19019,7 @@
                   <a:srgbClr val="6B7280"/>
                 </a:solidFill>
               </a:rPr>
-              <a:t>Porta 8000</a:t>
+              <a:t>Porta 9099</a:t>
             </a:r>
           </a:p>
         </p:txBody>
@@ -19053,7 +19053,7 @@
                   <a:srgbClr val="1A1A2E"/>
                 </a:solidFill>
               </a:rPr>
-              <a:t>Gateway REST da aplicação</a:t>
+              <a:t>Proxy /v1/messages — mock ou Ollama</a:t>
             </a:r>
           </a:p>
         </p:txBody>
@@ -19132,7 +19132,7 @@
                   <a:srgbClr val="FFFFFF"/>
                 </a:solidFill>
               </a:rPr>
-              <a:t>Dramatiq Workers</a:t>
+              <a:t>FastAPI App</a:t>
             </a:r>
           </a:p>
         </p:txBody>
@@ -19166,7 +19166,7 @@
                   <a:srgbClr val="6B7280"/>
                 </a:solidFill>
               </a:rPr>
-              <a:t>—</a:t>
+              <a:t>Porta 8000</a:t>
             </a:r>
           </a:p>
         </p:txBody>
@@ -19200,7 +19200,7 @@
                   <a:srgbClr val="1A1A2E"/>
                 </a:solidFill>
               </a:rPr>
-              <a:t>Processamento assíncrono de conversões</a:t>
+              <a:t>Gateway REST da aplicação</a:t>
             </a:r>
           </a:p>
         </p:txBody>
@@ -19268,7 +19268,7 @@
                   <a:srgbClr val="6B7280"/>
                 </a:solidFill>
               </a:rPr>
-              <a:t>FHIR-Forge v0.1.0  |  Abril 2026  |  Apache-2.0  |  Cassiano Moralles</a:t>
+              <a:t>FHIR-Forge v2  |  Abril 2026  |  Apache-2.0  |  Cassiano Moralles</a:t>
             </a:r>
           </a:p>
         </p:txBody>

</xml_diff>

<commit_message>
docs: regenerate PPTX/DOCX architecture for v2.1
Update generator scripts (footer, KPIs, metrics tables,
status row) for v2.1 baseline:
- 252 -> 289 unit tests
- add 'integration' KPI (3 tests via testcontainer)
- 'tag v2' -> 'tag v2.1' in title cells

Regenerate the two binary artifacts.

Co-Authored-By: Claude Opus 4.7 <noreply@anthropic.com>
</commit_message>
<xml_diff>
--- a/docs/fhir-forge-arquitetura.pptx
+++ b/docs/fhir-forge-arquitetura.pptx
@@ -4043,7 +4043,7 @@
                   <a:srgbClr val="6B7280"/>
                 </a:solidFill>
               </a:rPr>
-              <a:t>FHIR-Forge v2  |  Abril 2026  |  Apache-2.0  |  Cassiano Moralles</a:t>
+              <a:t>FHIR-Forge v2.1  |  Abril 2026  |  Apache-2.0  |  Cassiano Moralles</a:t>
             </a:r>
           </a:p>
         </p:txBody>
@@ -4999,7 +4999,7 @@
                   <a:srgbClr val="6B7280"/>
                 </a:solidFill>
               </a:rPr>
-              <a:t>FHIR-Forge v2  |  Abril 2026  |  Apache-2.0  |  Cassiano Moralles</a:t>
+              <a:t>FHIR-Forge v2.1  |  Abril 2026  |  Apache-2.0  |  Cassiano Moralles</a:t>
             </a:r>
           </a:p>
         </p:txBody>
@@ -6178,7 +6178,7 @@
                   <a:srgbClr val="6B7280"/>
                 </a:solidFill>
               </a:rPr>
-              <a:t>FHIR-Forge v2  |  Abril 2026  |  Apache-2.0  |  Cassiano Moralles</a:t>
+              <a:t>FHIR-Forge v2.1  |  Abril 2026  |  Apache-2.0  |  Cassiano Moralles</a:t>
             </a:r>
           </a:p>
         </p:txBody>
@@ -7684,7 +7684,7 @@
                   <a:srgbClr val="6B7280"/>
                 </a:solidFill>
               </a:rPr>
-              <a:t>FHIR-Forge v2  |  Abril 2026  |  Apache-2.0  |  Cassiano Moralles</a:t>
+              <a:t>FHIR-Forge v2.1  |  Abril 2026  |  Apache-2.0  |  Cassiano Moralles</a:t>
             </a:r>
           </a:p>
         </p:txBody>
@@ -8493,7 +8493,7 @@
                   <a:srgbClr val="6B7280"/>
                 </a:solidFill>
               </a:rPr>
-              <a:t>FHIR-Forge v2  |  Abril 2026  |  Apache-2.0  |  Cassiano Moralles</a:t>
+              <a:t>FHIR-Forge v2.1  |  Abril 2026  |  Apache-2.0  |  Cassiano Moralles</a:t>
             </a:r>
           </a:p>
         </p:txBody>
@@ -8570,7 +8570,7 @@
                   <a:srgbClr val="FFFFFF"/>
                 </a:solidFill>
               </a:rPr>
-              <a:t>  Estratégia de Testes: 252 Unit + 6 E2E, 91% de Cobertura</a:t>
+              <a:t>  Estratégia de Testes: 289 Unit + 3 Integration + 7 Regression + 6 E2E, 91% Cobertura</a:t>
             </a:r>
           </a:p>
         </p:txBody>
@@ -10889,7 +10889,7 @@
                   <a:srgbClr val="FFFFFF"/>
                 </a:solidFill>
               </a:rPr>
-              <a:t>252</a:t>
+              <a:t>289</a:t>
             </a:r>
           </a:p>
         </p:txBody>
@@ -11296,7 +11296,7 @@
                   <a:srgbClr val="6B7280"/>
                 </a:solidFill>
               </a:rPr>
-              <a:t>FHIR-Forge v2  |  Abril 2026  |  Apache-2.0  |  Cassiano Moralles</a:t>
+              <a:t>FHIR-Forge v2.1  |  Abril 2026  |  Apache-2.0  |  Cassiano Moralles</a:t>
             </a:r>
           </a:p>
         </p:txBody>
@@ -12347,7 +12347,7 @@
                   <a:srgbClr val="6B7280"/>
                 </a:solidFill>
               </a:rPr>
-              <a:t>FHIR-Forge v2  |  Abril 2026  |  Apache-2.0  |  Cassiano Moralles</a:t>
+              <a:t>FHIR-Forge v2.1  |  Abril 2026  |  Apache-2.0  |  Cassiano Moralles</a:t>
             </a:r>
           </a:p>
         </p:txBody>
@@ -12503,7 +12503,7 @@
                   <a:srgbClr val="FFFFFF"/>
                 </a:solidFill>
               </a:rPr>
-              <a:t>252</a:t>
+              <a:t>289</a:t>
             </a:r>
           </a:p>
         </p:txBody>
@@ -12616,7 +12616,7 @@
                   <a:srgbClr val="FFFFFF"/>
                 </a:solidFill>
               </a:rPr>
-              <a:t>6</a:t>
+              <a:t>3</a:t>
             </a:r>
           </a:p>
         </p:txBody>
@@ -12650,7 +12650,7 @@
                   <a:srgbClr val="FFFFFF"/>
                 </a:solidFill>
               </a:rPr>
-              <a:t>testes e2e validados</a:t>
+              <a:t>testes integration</a:t>
             </a:r>
           </a:p>
         </p:txBody>
@@ -13377,7 +13377,7 @@
                   <a:srgbClr val="6B7280"/>
                 </a:solidFill>
               </a:rPr>
-              <a:t>FHIR-Forge v2  |  Abril 2026  |  Apache-2.0  |  Cassiano Moralles</a:t>
+              <a:t>FHIR-Forge v2.1  |  Abril 2026  |  Apache-2.0  |  Cassiano Moralles</a:t>
             </a:r>
           </a:p>
         </p:txBody>
@@ -14166,7 +14166,7 @@
                   <a:srgbClr val="6B7280"/>
                 </a:solidFill>
               </a:rPr>
-              <a:t>FHIR-Forge v2  |  Abril 2026  |  Apache-2.0  |  Cassiano Moralles</a:t>
+              <a:t>FHIR-Forge v2.1  |  Abril 2026  |  Apache-2.0  |  Cassiano Moralles</a:t>
             </a:r>
           </a:p>
         </p:txBody>
@@ -14787,7 +14787,7 @@
                   <a:srgbClr val="6B7280"/>
                 </a:solidFill>
               </a:rPr>
-              <a:t>FHIR-Forge v2  |  Abril 2026  |  Apache-2.0  |  Cassiano Moralles</a:t>
+              <a:t>FHIR-Forge v2.1  |  Abril 2026  |  Apache-2.0  |  Cassiano Moralles</a:t>
             </a:r>
           </a:p>
         </p:txBody>
@@ -15516,7 +15516,7 @@
                   <a:srgbClr val="6B7280"/>
                 </a:solidFill>
               </a:rPr>
-              <a:t>FHIR-Forge v2  |  Abril 2026  |  Apache-2.0  |  Cassiano Moralles</a:t>
+              <a:t>FHIR-Forge v2.1  |  Abril 2026  |  Apache-2.0  |  Cassiano Moralles</a:t>
             </a:r>
           </a:p>
         </p:txBody>
@@ -16328,7 +16328,7 @@
                   <a:srgbClr val="6B7280"/>
                 </a:solidFill>
               </a:rPr>
-              <a:t>FHIR-Forge v2  |  Abril 2026  |  Apache-2.0  |  Cassiano Moralles</a:t>
+              <a:t>FHIR-Forge v2.1  |  Abril 2026  |  Apache-2.0  |  Cassiano Moralles</a:t>
             </a:r>
           </a:p>
         </p:txBody>
@@ -17148,7 +17148,7 @@
                   <a:srgbClr val="6B7280"/>
                 </a:solidFill>
               </a:rPr>
-              <a:t>FHIR-Forge v2  |  Abril 2026  |  Apache-2.0  |  Cassiano Moralles</a:t>
+              <a:t>FHIR-Forge v2.1  |  Abril 2026  |  Apache-2.0  |  Cassiano Moralles</a:t>
             </a:r>
           </a:p>
         </p:txBody>
@@ -17800,7 +17800,7 @@
                   <a:srgbClr val="6B7280"/>
                 </a:solidFill>
               </a:rPr>
-              <a:t>FHIR-Forge v2  |  Abril 2026  |  Apache-2.0  |  Cassiano Moralles</a:t>
+              <a:t>FHIR-Forge v2.1  |  Abril 2026  |  Apache-2.0  |  Cassiano Moralles</a:t>
             </a:r>
           </a:p>
         </p:txBody>
@@ -19268,7 +19268,7 @@
                   <a:srgbClr val="6B7280"/>
                 </a:solidFill>
               </a:rPr>
-              <a:t>FHIR-Forge v2  |  Abril 2026  |  Apache-2.0  |  Cassiano Moralles</a:t>
+              <a:t>FHIR-Forge v2.1  |  Abril 2026  |  Apache-2.0  |  Cassiano Moralles</a:t>
             </a:r>
           </a:p>
         </p:txBody>

</xml_diff>